<commit_message>
Add Thai deck; make the deck builder bilingual
Slide copy moves to deck_content.py keyed by language, so layout stays
shared and the two decks cannot drift apart structurally. Numbers are still
read from the summary JSONs at build time, and the verdict string is
translated through a map keyed on the exact strings the pipeline emits, so
an unrecognised verdict falls through to English rather than showing a
stale translation.

Thai defaults to Sukhumvit Set (ships with macOS); --font Tahoma for a face
present on both macOS and Windows. Figures keep English axis labels in both.

Co-Authored-By: Claude Opus 5 <noreply@anthropic.com>
</commit_message>
<xml_diff>
--- a/MTBLS242_forecast/mtbls242_forecast_correction.pptx
+++ b/MTBLS242_forecast/mtbls242_forecast_correction.pptx
@@ -3167,7 +3167,7 @@
               </a:lnSpc>
             </a:pPr>
             <a:r>
-              <a:rPr sz="5400" b="1" i="0">
+              <a:rPr sz="5000" b="1" i="0">
                 <a:solidFill>
                   <a:srgbClr val="1A1A1A"/>
                 </a:solidFill>
@@ -3362,7 +3362,7 @@
               </a:lnSpc>
             </a:pPr>
             <a:r>
-              <a:rPr sz="3000" b="1" i="0">
+              <a:rPr sz="2700" b="1" i="0">
                 <a:solidFill>
                   <a:srgbClr val="1A1A1A"/>
                 </a:solidFill>
@@ -3484,7 +3484,7 @@
               </a:lnSpc>
             </a:pPr>
             <a:r>
-              <a:rPr sz="1700" b="1" i="0">
+              <a:rPr sz="1600" b="1" i="0">
                 <a:solidFill>
                   <a:srgbClr val="1A1A1A"/>
                 </a:solidFill>
@@ -3523,7 +3523,7 @@
               </a:lnSpc>
             </a:pPr>
             <a:r>
-              <a:rPr sz="1300" b="0" i="0">
+              <a:rPr sz="1250" b="0" i="0">
                 <a:solidFill>
                   <a:srgbClr val="666666"/>
                 </a:solidFill>
@@ -3601,7 +3601,7 @@
               </a:lnSpc>
             </a:pPr>
             <a:r>
-              <a:rPr sz="1700" b="1" i="0">
+              <a:rPr sz="1600" b="1" i="0">
                 <a:solidFill>
                   <a:srgbClr val="1A1A1A"/>
                 </a:solidFill>
@@ -3640,7 +3640,7 @@
               </a:lnSpc>
             </a:pPr>
             <a:r>
-              <a:rPr sz="1300" b="0" i="0">
+              <a:rPr sz="1250" b="0" i="0">
                 <a:solidFill>
                   <a:srgbClr val="666666"/>
                 </a:solidFill>
@@ -3718,7 +3718,7 @@
               </a:lnSpc>
             </a:pPr>
             <a:r>
-              <a:rPr sz="1700" b="1" i="0">
+              <a:rPr sz="1600" b="1" i="0">
                 <a:solidFill>
                   <a:srgbClr val="1A1A1A"/>
                 </a:solidFill>
@@ -3757,7 +3757,7 @@
               </a:lnSpc>
             </a:pPr>
             <a:r>
-              <a:rPr sz="1300" b="0" i="0">
+              <a:rPr sz="1250" b="0" i="0">
                 <a:solidFill>
                   <a:srgbClr val="666666"/>
                 </a:solidFill>
@@ -3840,7 +3840,7 @@
               </a:lnSpc>
             </a:pPr>
             <a:r>
-              <a:rPr sz="1300" b="0" i="0">
+              <a:rPr sz="1250" b="0" i="0">
                 <a:solidFill>
                   <a:srgbClr val="666666"/>
                 </a:solidFill>
@@ -3856,7 +3856,7 @@
               </a:lnSpc>
             </a:pPr>
             <a:r>
-              <a:rPr sz="1300" b="0" i="0">
+              <a:rPr sz="1250" b="0" i="0">
                 <a:solidFill>
                   <a:srgbClr val="666666"/>
                 </a:solidFill>
@@ -3952,7 +3952,7 @@
               </a:lnSpc>
             </a:pPr>
             <a:r>
-              <a:rPr sz="3000" b="1" i="0">
+              <a:rPr sz="2700" b="1" i="0">
                 <a:solidFill>
                   <a:srgbClr val="1A1A1A"/>
                 </a:solidFill>
@@ -4059,7 +4059,7 @@
               </a:lnSpc>
             </a:pPr>
             <a:r>
-              <a:rPr sz="1300" b="0" i="0">
+              <a:rPr sz="1250" b="0" i="0">
                 <a:solidFill>
                   <a:srgbClr val="1A1A1A"/>
                 </a:solidFill>
@@ -4075,7 +4075,7 @@
               </a:lnSpc>
             </a:pPr>
             <a:r>
-              <a:rPr sz="1300" b="0" i="0">
+              <a:rPr sz="1250" b="0" i="0">
                 <a:solidFill>
                   <a:srgbClr val="1A1A1A"/>
                 </a:solidFill>
@@ -4091,7 +4091,7 @@
               </a:lnSpc>
             </a:pPr>
             <a:r>
-              <a:rPr sz="1300" b="0" i="0">
+              <a:rPr sz="1250" b="0" i="0">
                 <a:solidFill>
                   <a:srgbClr val="1A1A1A"/>
                 </a:solidFill>
@@ -4107,13 +4107,29 @@
               </a:lnSpc>
             </a:pPr>
             <a:r>
-              <a:rPr sz="1300" b="0" i="0">
+              <a:rPr sz="1250" b="0" i="0">
                 <a:solidFill>
                   <a:srgbClr val="1A1A1A"/>
                 </a:solidFill>
                 <a:latin typeface="Helvetica Neue"/>
               </a:rPr>
-              <a:t>The pooled R² of 0.931 is not performance: it is driven by scale differences between metabolites. Median per-metabolite R² is -0.013.</a:t>
+              <a:t>The pooled R² of 0.931 is not performance: it is driven by scale differences between metabolites. Median</a:t>
+            </a:r>
+          </a:p>
+          <a:p>
+            <a:pPr algn="l">
+              <a:lnSpc>
+                <a:spcPct val="130000"/>
+              </a:lnSpc>
+            </a:pPr>
+            <a:r>
+              <a:rPr sz="1250" b="0" i="0">
+                <a:solidFill>
+                  <a:srgbClr val="1A1A1A"/>
+                </a:solidFill>
+                <a:latin typeface="Helvetica Neue"/>
+              </a:rPr>
+              <a:t>per-metabolite R² is -0.013.</a:t>
             </a:r>
           </a:p>
         </p:txBody>
@@ -4203,7 +4219,7 @@
               </a:lnSpc>
             </a:pPr>
             <a:r>
-              <a:rPr sz="3000" b="1" i="0">
+              <a:rPr sz="2700" b="1" i="0">
                 <a:solidFill>
                   <a:srgbClr val="1A1A1A"/>
                 </a:solidFill>
@@ -4286,7 +4302,7 @@
               </a:lnSpc>
             </a:pPr>
             <a:r>
-              <a:rPr sz="1500" b="1" i="0">
+              <a:rPr sz="1450" b="1" i="0">
                 <a:solidFill>
                   <a:srgbClr val="1F6F8B"/>
                 </a:solidFill>
@@ -4325,7 +4341,7 @@
               </a:lnSpc>
             </a:pPr>
             <a:r>
-              <a:rPr sz="1250" b="0" i="0">
+              <a:rPr sz="1200" b="0" i="0">
                 <a:solidFill>
                   <a:srgbClr val="1A1A1A"/>
                 </a:solidFill>
@@ -4364,7 +4380,7 @@
               </a:lnSpc>
             </a:pPr>
             <a:r>
-              <a:rPr sz="1500" b="1" i="0">
+              <a:rPr sz="1450" b="1" i="0">
                 <a:solidFill>
                   <a:srgbClr val="1F6F8B"/>
                 </a:solidFill>
@@ -4403,7 +4419,7 @@
               </a:lnSpc>
             </a:pPr>
             <a:r>
-              <a:rPr sz="1250" b="0" i="0">
+              <a:rPr sz="1200" b="0" i="0">
                 <a:solidFill>
                   <a:srgbClr val="1A1A1A"/>
                 </a:solidFill>
@@ -4442,7 +4458,7 @@
               </a:lnSpc>
             </a:pPr>
             <a:r>
-              <a:rPr sz="1500" b="1" i="0">
+              <a:rPr sz="1450" b="1" i="0">
                 <a:solidFill>
                   <a:srgbClr val="1F6F8B"/>
                 </a:solidFill>
@@ -4481,7 +4497,7 @@
               </a:lnSpc>
             </a:pPr>
             <a:r>
-              <a:rPr sz="1250" b="0" i="0">
+              <a:rPr sz="1200" b="0" i="0">
                 <a:solidFill>
                   <a:srgbClr val="1A1A1A"/>
                 </a:solidFill>
@@ -4520,7 +4536,7 @@
               </a:lnSpc>
             </a:pPr>
             <a:r>
-              <a:rPr sz="1500" b="1" i="0">
+              <a:rPr sz="1450" b="1" i="0">
                 <a:solidFill>
                   <a:srgbClr val="1F6F8B"/>
                 </a:solidFill>
@@ -4559,7 +4575,7 @@
               </a:lnSpc>
             </a:pPr>
             <a:r>
-              <a:rPr sz="1250" b="0" i="0">
+              <a:rPr sz="1200" b="0" i="0">
                 <a:solidFill>
                   <a:srgbClr val="1A1A1A"/>
                 </a:solidFill>
@@ -4642,7 +4658,7 @@
               </a:lnSpc>
             </a:pPr>
             <a:r>
-              <a:rPr sz="1300" b="1" i="0">
+              <a:rPr sz="1250" b="1" i="0">
                 <a:solidFill>
                   <a:srgbClr val="1A1A1A"/>
                 </a:solidFill>
@@ -4738,7 +4754,7 @@
               </a:lnSpc>
             </a:pPr>
             <a:r>
-              <a:rPr sz="3000" b="1" i="0">
+              <a:rPr sz="2700" b="1" i="0">
                 <a:solidFill>
                   <a:srgbClr val="1A1A1A"/>
                 </a:solidFill>
@@ -4821,7 +4837,7 @@
               </a:lnSpc>
             </a:pPr>
             <a:r>
-              <a:rPr sz="1800" b="0" i="0">
+              <a:rPr sz="1700" b="0" i="0">
                 <a:solidFill>
                   <a:srgbClr val="1A1A1A"/>
                 </a:solidFill>
@@ -4837,7 +4853,7 @@
               </a:lnSpc>
             </a:pPr>
             <a:r>
-              <a:rPr sz="1800" b="0" i="0">
+              <a:rPr sz="1700" b="0" i="0">
                 <a:solidFill>
                   <a:srgbClr val="1A1A1A"/>
                 </a:solidFill>
@@ -4853,7 +4869,7 @@
               </a:lnSpc>
             </a:pPr>
             <a:r>
-              <a:rPr sz="1800" b="0" i="0">
+              <a:rPr sz="1700" b="0" i="0">
                 <a:solidFill>
                   <a:srgbClr val="1A1A1A"/>
                 </a:solidFill>
@@ -4869,7 +4885,7 @@
               </a:lnSpc>
             </a:pPr>
             <a:r>
-              <a:rPr sz="1800" b="0" i="0">
+              <a:rPr sz="1700" b="0" i="0">
                 <a:solidFill>
                   <a:srgbClr val="1A1A1A"/>
                 </a:solidFill>
@@ -4885,7 +4901,7 @@
               </a:lnSpc>
             </a:pPr>
             <a:r>
-              <a:rPr sz="1800" b="0" i="0">
+              <a:rPr sz="1700" b="0" i="0">
                 <a:solidFill>
                   <a:srgbClr val="1A1A1A"/>
                 </a:solidFill>
@@ -4901,7 +4917,7 @@
               </a:lnSpc>
             </a:pPr>
             <a:r>
-              <a:rPr sz="1800" b="0" i="0">
+              <a:rPr sz="1700" b="0" i="0">
                 <a:solidFill>
                   <a:srgbClr val="1A1A1A"/>
                 </a:solidFill>
@@ -4920,7 +4936,7 @@
         </p:nvSpPr>
         <p:spPr>
           <a:xfrm>
-            <a:off x="685800" y="4754880"/>
+            <a:off x="685800" y="4892040"/>
             <a:ext cx="10820095" cy="9525"/>
           </a:xfrm>
           <a:prstGeom prst="rect">
@@ -4964,7 +4980,7 @@
         </p:nvSpPr>
         <p:spPr>
           <a:xfrm>
-            <a:off x="685800" y="4937760"/>
+            <a:off x="685800" y="5074920"/>
             <a:ext cx="10820095" cy="1280160"/>
           </a:xfrm>
           <a:prstGeom prst="rect">
@@ -4984,7 +5000,7 @@
               </a:lnSpc>
             </a:pPr>
             <a:r>
-              <a:rPr sz="1200" b="0" i="0">
+              <a:rPr sz="1150" b="0" i="0">
                 <a:solidFill>
                   <a:srgbClr val="666666"/>
                 </a:solidFill>
@@ -5000,7 +5016,7 @@
               </a:lnSpc>
             </a:pPr>
             <a:r>
-              <a:rPr sz="1200" b="0" i="0">
+              <a:rPr sz="1150" b="0" i="0">
                 <a:solidFill>
                   <a:srgbClr val="666666"/>
                 </a:solidFill>
@@ -5016,7 +5032,7 @@
               </a:lnSpc>
             </a:pPr>
             <a:r>
-              <a:rPr sz="1200" b="0" i="0">
+              <a:rPr sz="1150" b="0" i="0">
                 <a:solidFill>
                   <a:srgbClr val="666666"/>
                 </a:solidFill>
@@ -5112,7 +5128,7 @@
               </a:lnSpc>
             </a:pPr>
             <a:r>
-              <a:rPr sz="3000" b="1" i="0">
+              <a:rPr sz="2700" b="1" i="0">
                 <a:solidFill>
                   <a:srgbClr val="1A1A1A"/>
                 </a:solidFill>
@@ -5195,7 +5211,7 @@
               </a:lnSpc>
             </a:pPr>
             <a:r>
-              <a:rPr sz="2200" b="0" i="0">
+              <a:rPr sz="2100" b="0" i="0">
                 <a:solidFill>
                   <a:srgbClr val="1A1A1A"/>
                 </a:solidFill>
@@ -5211,7 +5227,7 @@
               </a:lnSpc>
             </a:pPr>
             <a:r>
-              <a:rPr sz="2200" b="0" i="0">
+              <a:rPr sz="2100" b="0" i="0">
                 <a:solidFill>
                   <a:srgbClr val="1A1A1A"/>
                 </a:solidFill>
@@ -5644,7 +5660,7 @@
               </a:lnSpc>
             </a:pPr>
             <a:r>
-              <a:rPr sz="3000" b="1" i="0">
+              <a:rPr sz="2700" b="1" i="0">
                 <a:solidFill>
                   <a:srgbClr val="1A1A1A"/>
                 </a:solidFill>
@@ -6089,7 +6105,7 @@
               </a:lnSpc>
             </a:pPr>
             <a:r>
-              <a:rPr sz="3000" b="1" i="0">
+              <a:rPr sz="2700" b="1" i="0">
                 <a:solidFill>
                   <a:srgbClr val="1A1A1A"/>
                 </a:solidFill>
@@ -6172,7 +6188,7 @@
               </a:lnSpc>
             </a:pPr>
             <a:r>
-              <a:rPr sz="1300" b="0" i="0">
+              <a:rPr sz="1250" b="0" i="0">
                 <a:solidFill>
                   <a:srgbClr val="666666"/>
                 </a:solidFill>
@@ -6188,7 +6204,7 @@
               </a:lnSpc>
             </a:pPr>
             <a:r>
-              <a:rPr sz="1300" b="0" i="0">
+              <a:rPr sz="1250" b="0" i="0">
                 <a:solidFill>
                   <a:srgbClr val="666666"/>
                 </a:solidFill>
@@ -6347,7 +6363,7 @@
               </a:lnSpc>
             </a:pPr>
             <a:r>
-              <a:rPr sz="3000" b="1" i="0">
+              <a:rPr sz="2700" b="1" i="0">
                 <a:solidFill>
                   <a:srgbClr val="1A1A1A"/>
                 </a:solidFill>
@@ -6430,7 +6446,7 @@
               </a:lnSpc>
             </a:pPr>
             <a:r>
-              <a:rPr sz="1400" b="0" i="0">
+              <a:rPr sz="1350" b="0" i="0">
                 <a:solidFill>
                   <a:srgbClr val="1A1A1A"/>
                 </a:solidFill>
@@ -6446,7 +6462,7 @@
               </a:lnSpc>
             </a:pPr>
             <a:r>
-              <a:rPr sz="1400" b="0" i="0">
+              <a:rPr sz="1350" b="0" i="0">
                 <a:solidFill>
                   <a:srgbClr val="1A1A1A"/>
                 </a:solidFill>
@@ -6719,7 +6735,7 @@
               </a:lnSpc>
             </a:pPr>
             <a:r>
-              <a:rPr sz="2200" b="1" i="0">
+              <a:rPr sz="2100" b="1" i="0">
                 <a:solidFill>
                   <a:srgbClr val="B2182B"/>
                 </a:solidFill>
@@ -6735,7 +6751,7 @@
               </a:lnSpc>
             </a:pPr>
             <a:r>
-              <a:rPr sz="2200" b="1" i="0">
+              <a:rPr sz="2100" b="1" i="0">
                 <a:solidFill>
                   <a:srgbClr val="B2182B"/>
                 </a:solidFill>
@@ -6831,7 +6847,7 @@
               </a:lnSpc>
             </a:pPr>
             <a:r>
-              <a:rPr sz="3000" b="1" i="0">
+              <a:rPr sz="2700" b="1" i="0">
                 <a:solidFill>
                   <a:srgbClr val="1A1A1A"/>
                 </a:solidFill>
@@ -6914,7 +6930,7 @@
               </a:lnSpc>
             </a:pPr>
             <a:r>
-              <a:rPr sz="1600" b="0" i="0">
+              <a:rPr sz="1550" b="0" i="0">
                 <a:solidFill>
                   <a:srgbClr val="666666"/>
                 </a:solidFill>
@@ -6953,7 +6969,7 @@
               </a:lnSpc>
             </a:pPr>
             <a:r>
-              <a:rPr sz="5200" b="1" i="0">
+              <a:rPr sz="5000" b="1" i="0">
                 <a:solidFill>
                   <a:srgbClr val="B2182B"/>
                 </a:solidFill>
@@ -6992,7 +7008,7 @@
               </a:lnSpc>
             </a:pPr>
             <a:r>
-              <a:rPr sz="1700" b="0" i="0">
+              <a:rPr sz="1600" b="0" i="0">
                 <a:solidFill>
                   <a:srgbClr val="1A1A1A"/>
                 </a:solidFill>
@@ -7008,7 +7024,7 @@
               </a:lnSpc>
             </a:pPr>
             <a:r>
-              <a:rPr sz="1700" b="0" i="0">
+              <a:rPr sz="1600" b="0" i="0">
                 <a:solidFill>
                   <a:srgbClr val="1A1A1A"/>
                 </a:solidFill>
@@ -7024,7 +7040,7 @@
               </a:lnSpc>
             </a:pPr>
             <a:r>
-              <a:rPr sz="1700" b="0" i="0">
+              <a:rPr sz="1600" b="0" i="0">
                 <a:solidFill>
                   <a:srgbClr val="1A1A1A"/>
                 </a:solidFill>
@@ -7040,7 +7056,7 @@
               </a:lnSpc>
             </a:pPr>
             <a:r>
-              <a:rPr sz="1700" b="0" i="0">
+              <a:rPr sz="1600" b="0" i="0">
                 <a:solidFill>
                   <a:srgbClr val="1A1A1A"/>
                 </a:solidFill>
@@ -7059,7 +7075,7 @@
         </p:nvSpPr>
         <p:spPr>
           <a:xfrm>
-            <a:off x="685800" y="5349240"/>
+            <a:off x="685800" y="5440680"/>
             <a:ext cx="10820095" cy="9525"/>
           </a:xfrm>
           <a:prstGeom prst="rect">
@@ -7103,7 +7119,7 @@
         </p:nvSpPr>
         <p:spPr>
           <a:xfrm>
-            <a:off x="685800" y="5532120"/>
+            <a:off x="685800" y="5623560"/>
             <a:ext cx="10820095" cy="822960"/>
           </a:xfrm>
           <a:prstGeom prst="rect">
@@ -7123,7 +7139,7 @@
               </a:lnSpc>
             </a:pPr>
             <a:r>
-              <a:rPr sz="1500" b="1" i="0">
+              <a:rPr sz="1450" b="1" i="0">
                 <a:solidFill>
                   <a:srgbClr val="1A1A1A"/>
                 </a:solidFill>
@@ -7139,7 +7155,7 @@
               </a:lnSpc>
             </a:pPr>
             <a:r>
-              <a:rPr sz="1500" b="1" i="0">
+              <a:rPr sz="1450" b="1" i="0">
                 <a:solidFill>
                   <a:srgbClr val="1A1A1A"/>
                 </a:solidFill>
@@ -7235,7 +7251,7 @@
               </a:lnSpc>
             </a:pPr>
             <a:r>
-              <a:rPr sz="3000" b="1" i="0">
+              <a:rPr sz="2700" b="1" i="0">
                 <a:solidFill>
                   <a:srgbClr val="1A1A1A"/>
                 </a:solidFill>
@@ -7600,7 +7616,7 @@
               </a:lnSpc>
             </a:pPr>
             <a:r>
-              <a:rPr sz="1400" b="0" i="0">
+              <a:rPr sz="1350" b="0" i="0">
                 <a:solidFill>
                   <a:srgbClr val="1A1A1A"/>
                 </a:solidFill>
@@ -7616,7 +7632,7 @@
               </a:lnSpc>
             </a:pPr>
             <a:r>
-              <a:rPr sz="1400" b="0" i="0">
+              <a:rPr sz="1350" b="0" i="0">
                 <a:solidFill>
                   <a:srgbClr val="1A1A1A"/>
                 </a:solidFill>
@@ -7632,7 +7648,7 @@
               </a:lnSpc>
             </a:pPr>
             <a:r>
-              <a:rPr sz="1400" b="0" i="0">
+              <a:rPr sz="1350" b="0" i="0">
                 <a:solidFill>
                   <a:srgbClr val="1A1A1A"/>
                 </a:solidFill>
@@ -7648,7 +7664,7 @@
               </a:lnSpc>
             </a:pPr>
             <a:r>
-              <a:rPr sz="1400" b="0" i="0">
+              <a:rPr sz="1350" b="0" i="0">
                 <a:solidFill>
                   <a:srgbClr val="1A1A1A"/>
                 </a:solidFill>
@@ -7664,7 +7680,7 @@
               </a:lnSpc>
             </a:pPr>
             <a:r>
-              <a:rPr sz="1400" b="0" i="0">
+              <a:rPr sz="1350" b="0" i="0">
                 <a:solidFill>
                   <a:srgbClr val="1A1A1A"/>
                 </a:solidFill>
@@ -7680,7 +7696,7 @@
               </a:lnSpc>
             </a:pPr>
             <a:r>
-              <a:rPr sz="1400" b="0" i="0">
+              <a:rPr sz="1350" b="0" i="0">
                 <a:solidFill>
                   <a:srgbClr val="1A1A1A"/>
                 </a:solidFill>
@@ -7776,7 +7792,7 @@
               </a:lnSpc>
             </a:pPr>
             <a:r>
-              <a:rPr sz="3000" b="1" i="0">
+              <a:rPr sz="2700" b="1" i="0">
                 <a:solidFill>
                   <a:srgbClr val="1A1A1A"/>
                 </a:solidFill>
@@ -8433,7 +8449,7 @@
               </a:lnSpc>
             </a:pPr>
             <a:r>
-              <a:rPr sz="1200" b="0" i="0">
+              <a:rPr sz="1150" b="0" i="0">
                 <a:solidFill>
                   <a:srgbClr val="666666"/>
                 </a:solidFill>
@@ -8449,7 +8465,7 @@
               </a:lnSpc>
             </a:pPr>
             <a:r>
-              <a:rPr sz="1200" b="0" i="0">
+              <a:rPr sz="1150" b="0" i="0">
                 <a:solidFill>
                   <a:srgbClr val="666666"/>
                 </a:solidFill>
@@ -8465,7 +8481,7 @@
               </a:lnSpc>
             </a:pPr>
             <a:r>
-              <a:rPr sz="1200" b="0" i="0">
+              <a:rPr sz="1150" b="0" i="0">
                 <a:solidFill>
                   <a:srgbClr val="666666"/>
                 </a:solidFill>
@@ -8561,7 +8577,7 @@
               </a:lnSpc>
             </a:pPr>
             <a:r>
-              <a:rPr sz="3000" b="1" i="0">
+              <a:rPr sz="2700" b="1" i="0">
                 <a:solidFill>
                   <a:srgbClr val="1A1A1A"/>
                 </a:solidFill>
@@ -8950,7 +8966,7 @@
               </a:lnSpc>
             </a:pPr>
             <a:r>
-              <a:rPr sz="2000" b="1" i="0">
+              <a:rPr sz="1700" b="1" i="0">
                 <a:solidFill>
                   <a:srgbClr val="B2182B"/>
                 </a:solidFill>

</xml_diff>